<commit_message>
Remove slides 13 e 14
</commit_message>
<xml_diff>
--- a/presentation/apresentacao.pptx
+++ b/presentation/apresentacao.pptx
@@ -1,126 +1,80 @@
 
-<file path=ppt/presentation.xml><?xml version="1.0" encoding="utf-8"?>
-<p:presentation xmlns:a="http://schemas.openxmlformats.org/drawingml/2006/main" xmlns:r="http://schemas.openxmlformats.org/officeDocument/2006/relationships" xmlns:p="http://schemas.openxmlformats.org/presentationml/2006/main" saveSubsetFonts="1" autoCompressPictures="0">
-  <p:sldMasterIdLst>
-    <p:sldMasterId id="2147483648" r:id="rId1"/>
-  </p:sldMasterIdLst>
-  <p:sldIdLst>
-    <p:sldId id="256" r:id="rId2"/>
-    <p:sldId id="257" r:id="rId3"/>
-    <p:sldId id="258" r:id="rId4"/>
-    <p:sldId id="259" r:id="rId5"/>
-    <p:sldId id="260" r:id="rId6"/>
-    <p:sldId id="261" r:id="rId7"/>
-    <p:sldId id="262" r:id="rId8"/>
-    <p:sldId id="263" r:id="rId9"/>
-    <p:sldId id="264" r:id="rId10"/>
-    <p:sldId id="265" r:id="rId11"/>
-    <p:sldId id="266" r:id="rId12"/>
-    <p:sldId id="267" r:id="rId13"/>
-    <p:sldId id="268" r:id="rId14"/>
-    <p:sldId id="269" r:id="rId15"/>
-  </p:sldIdLst>
-  <p:notesMasterIdLst>
-    <p:notesMasterId r:id="rId16"/>
-  </p:notesMasterIdLst>
-  <p:sldSz cx="12192000" cy="6858000"/>
-  <p:notesSz cx="6858000" cy="12192000"/>
-  <p:defaultTextStyle>
-    <a:lvl1pPr marL="0" algn="l" defTabSz="914400" rtl="0" eaLnBrk="1" latinLnBrk="0" hangingPunct="1">
-      <a:defRPr sz="1800" kern="1200">
-        <a:solidFill>
-          <a:schemeClr val="tx1"/>
-        </a:solidFill>
-        <a:latin typeface="+mn-lt"/>
-        <a:ea typeface="+mn-ea"/>
-        <a:cs typeface="+mn-cs"/>
-      </a:defRPr>
-    </a:lvl1pPr>
-    <a:lvl2pPr marL="457200" algn="l" defTabSz="914400" rtl="0" eaLnBrk="1" latinLnBrk="0" hangingPunct="1">
-      <a:defRPr sz="1800" kern="1200">
-        <a:solidFill>
-          <a:schemeClr val="tx1"/>
-        </a:solidFill>
-        <a:latin typeface="+mn-lt"/>
-        <a:ea typeface="+mn-ea"/>
-        <a:cs typeface="+mn-cs"/>
-      </a:defRPr>
-    </a:lvl2pPr>
-    <a:lvl3pPr marL="914400" algn="l" defTabSz="914400" rtl="0" eaLnBrk="1" latinLnBrk="0" hangingPunct="1">
-      <a:defRPr sz="1800" kern="1200">
-        <a:solidFill>
-          <a:schemeClr val="tx1"/>
-        </a:solidFill>
-        <a:latin typeface="+mn-lt"/>
-        <a:ea typeface="+mn-ea"/>
-        <a:cs typeface="+mn-cs"/>
-      </a:defRPr>
-    </a:lvl3pPr>
-    <a:lvl4pPr marL="1371600" algn="l" defTabSz="914400" rtl="0" eaLnBrk="1" latinLnBrk="0" hangingPunct="1">
-      <a:defRPr sz="1800" kern="1200">
-        <a:solidFill>
-          <a:schemeClr val="tx1"/>
-        </a:solidFill>
-        <a:latin typeface="+mn-lt"/>
-        <a:ea typeface="+mn-ea"/>
-        <a:cs typeface="+mn-cs"/>
-      </a:defRPr>
-    </a:lvl4pPr>
-    <a:lvl5pPr marL="1828800" algn="l" defTabSz="914400" rtl="0" eaLnBrk="1" latinLnBrk="0" hangingPunct="1">
-      <a:defRPr sz="1800" kern="1200">
-        <a:solidFill>
-          <a:schemeClr val="tx1"/>
-        </a:solidFill>
-        <a:latin typeface="+mn-lt"/>
-        <a:ea typeface="+mn-ea"/>
-        <a:cs typeface="+mn-cs"/>
-      </a:defRPr>
-    </a:lvl5pPr>
-    <a:lvl6pPr marL="2286000" algn="l" defTabSz="914400" rtl="0" eaLnBrk="1" latinLnBrk="0" hangingPunct="1">
-      <a:defRPr sz="1800" kern="1200">
-        <a:solidFill>
-          <a:schemeClr val="tx1"/>
-        </a:solidFill>
-        <a:latin typeface="+mn-lt"/>
-        <a:ea typeface="+mn-ea"/>
-        <a:cs typeface="+mn-cs"/>
-      </a:defRPr>
-    </a:lvl6pPr>
-    <a:lvl7pPr marL="2743200" algn="l" defTabSz="914400" rtl="0" eaLnBrk="1" latinLnBrk="0" hangingPunct="1">
-      <a:defRPr sz="1800" kern="1200">
-        <a:solidFill>
-          <a:schemeClr val="tx1"/>
-        </a:solidFill>
-        <a:latin typeface="+mn-lt"/>
-        <a:ea typeface="+mn-ea"/>
-        <a:cs typeface="+mn-cs"/>
-      </a:defRPr>
-    </a:lvl7pPr>
-    <a:lvl8pPr marL="3200400" algn="l" defTabSz="914400" rtl="0" eaLnBrk="1" latinLnBrk="0" hangingPunct="1">
-      <a:defRPr sz="1800" kern="1200">
-        <a:solidFill>
-          <a:schemeClr val="tx1"/>
-        </a:solidFill>
-        <a:latin typeface="+mn-lt"/>
-        <a:ea typeface="+mn-ea"/>
-        <a:cs typeface="+mn-cs"/>
-      </a:defRPr>
-    </a:lvl8pPr>
-    <a:lvl9pPr marL="3657600" algn="l" defTabSz="914400" rtl="0" eaLnBrk="1" latinLnBrk="0" hangingPunct="1">
-      <a:defRPr sz="1800" kern="1200">
-        <a:solidFill>
-          <a:schemeClr val="tx1"/>
-        </a:solidFill>
-        <a:latin typeface="+mn-lt"/>
-        <a:ea typeface="+mn-ea"/>
-        <a:cs typeface="+mn-cs"/>
-      </a:defRPr>
-    </a:lvl9pPr>
-  </p:defaultTextStyle>
-</p:presentation>
+<file path=docProps\app.xml><?xml version="1.0" encoding="utf-8"?>
+<Properties xmlns="http://schemas.openxmlformats.org/officeDocument/2006/extended-properties" xmlns:vt="http://schemas.openxmlformats.org/officeDocument/2006/docPropsVTypes">
+  <TotalTime>0</TotalTime>
+  <Words>0</Words>
+  <Application>Microsoft Office PowerPoint</Application>
+  <PresentationFormat>On-screen Show (16:9)</PresentationFormat>
+  <Paragraphs>0</Paragraphs>
+  <Slides>14</Slides>
+  <Notes>14</Notes>
+  <HiddenSlides>0</HiddenSlides>
+  <MMClips>0</MMClips>
+  <ScaleCrop>false</ScaleCrop>
+  <HeadingPairs>
+    <vt:vector size="6" baseType="variant">
+      <vt:variant>
+        <vt:lpstr>Fonts Used</vt:lpstr>
+      </vt:variant>
+      <vt:variant>
+        <vt:i4>2</vt:i4>
+      </vt:variant>
+      <vt:variant>
+        <vt:lpstr>Theme</vt:lpstr>
+      </vt:variant>
+      <vt:variant>
+        <vt:i4>1</vt:i4>
+      </vt:variant>
+      <vt:variant>
+        <vt:lpstr>Slide Titles</vt:lpstr>
+      </vt:variant>
+      <vt:variant>
+        <vt:i4>14</vt:i4>
+      </vt:variant>
+    </vt:vector>
+  </HeadingPairs>
+  <TitlesOfParts>
+    <vt:vector size="17" baseType="lpstr">
+      <vt:lpstr>Arial</vt:lpstr>
+      <vt:lpstr>Calibri</vt:lpstr>
+      <vt:lpstr>Office Theme</vt:lpstr>
+      <vt:lpstr>Slide 1</vt:lpstr>
+      <vt:lpstr>Slide 2</vt:lpstr>
+      <vt:lpstr>Slide 3</vt:lpstr>
+      <vt:lpstr>Slide 4</vt:lpstr>
+      <vt:lpstr>Slide 5</vt:lpstr>
+      <vt:lpstr>Slide 6</vt:lpstr>
+      <vt:lpstr>Slide 7</vt:lpstr>
+      <vt:lpstr>Slide 8</vt:lpstr>
+      <vt:lpstr>Slide 9</vt:lpstr>
+      <vt:lpstr>Slide 10</vt:lpstr>
+      <vt:lpstr>Slide 11</vt:lpstr>
+      <vt:lpstr>Slide 12</vt:lpstr>
+      <vt:lpstr>Slide 13</vt:lpstr>
+      <vt:lpstr>Slide 14</vt:lpstr>
+    </vt:vector>
+  </TitlesOfParts>
+  <Company>PptxGenJS</Company>
+  <LinksUpToDate>false</LinksUpToDate>
+  <SharedDoc>false</SharedDoc>
+  <HyperlinksChanged>false</HyperlinksChanged>
+  <AppVersion>16.0000</AppVersion>
+</Properties>
 </file>
 
-<file path=ppt/notesMasters/notesMaster1.xml><?xml version="1.0" encoding="utf-8"?>
+<file path=docProps\core.xml><?xml version="1.0" encoding="utf-8"?>
+<cp:coreProperties xmlns:cp="http://schemas.openxmlformats.org/package/2006/metadata/core-properties" xmlns:dc="http://purl.org/dc/elements/1.1/" xmlns:dcterms="http://purl.org/dc/terms/" xmlns:dcmitype="http://purl.org/dc/dcmitype/" xmlns:xsi="http://www.w3.org/2001/XMLSchema-instance">
+  <dc:title>PptxGenJS Presentation</dc:title>
+  <dc:subject>PptxGenJS Presentation</dc:subject>
+  <dc:creator>PptxGenJS</dc:creator>
+  <cp:lastModifiedBy>PptxGenJS</cp:lastModifiedBy>
+  <cp:revision>1</cp:revision>
+  <dcterms:created xsi:type="dcterms:W3CDTF">2026-06-11T21:54:08Z</dcterms:created>
+  <dcterms:modified xsi:type="dcterms:W3CDTF">2026-06-11T21:54:08Z</dcterms:modified>
+</cp:coreProperties>
+</file>
+
+<file path=ppt\notesMasters\notesMaster1.xml><?xml version="1.0" encoding="utf-8"?>
 <p:notesMaster xmlns:a="http://schemas.openxmlformats.org/drawingml/2006/main" xmlns:r="http://schemas.openxmlformats.org/officeDocument/2006/relationships" xmlns:p="http://schemas.openxmlformats.org/presentationml/2006/main">
   <p:cSld>
     <p:bg>
@@ -469,7 +423,7 @@
 </p:notesMaster>
 </file>
 
-<file path=ppt/notesSlides/notesSlide1.xml><?xml version="1.0" encoding="utf-8"?>
+<file path=ppt\notesSlides\notesSlide1.xml><?xml version="1.0" encoding="utf-8"?>
 <p:notes xmlns:a="http://schemas.openxmlformats.org/drawingml/2006/main" xmlns:r="http://schemas.openxmlformats.org/officeDocument/2006/relationships" xmlns:p="http://schemas.openxmlformats.org/presentationml/2006/main">
   <p:cSld>
     <p:spTree>
@@ -557,7 +511,7 @@
 </p:notes>
 </file>
 
-<file path=ppt/notesSlides/notesSlide10.xml><?xml version="1.0" encoding="utf-8"?>
+<file path=ppt\notesSlides\notesSlide10.xml><?xml version="1.0" encoding="utf-8"?>
 <p:notes xmlns:a="http://schemas.openxmlformats.org/drawingml/2006/main" xmlns:r="http://schemas.openxmlformats.org/officeDocument/2006/relationships" xmlns:p="http://schemas.openxmlformats.org/presentationml/2006/main">
   <p:cSld>
     <p:spTree>
@@ -645,7 +599,7 @@
 </p:notes>
 </file>
 
-<file path=ppt/notesSlides/notesSlide11.xml><?xml version="1.0" encoding="utf-8"?>
+<file path=ppt\notesSlides\notesSlide11.xml><?xml version="1.0" encoding="utf-8"?>
 <p:notes xmlns:a="http://schemas.openxmlformats.org/drawingml/2006/main" xmlns:r="http://schemas.openxmlformats.org/officeDocument/2006/relationships" xmlns:p="http://schemas.openxmlformats.org/presentationml/2006/main">
   <p:cSld>
     <p:spTree>
@@ -733,7 +687,7 @@
 </p:notes>
 </file>
 
-<file path=ppt/notesSlides/notesSlide12.xml><?xml version="1.0" encoding="utf-8"?>
+<file path=ppt\notesSlides\notesSlide12.xml><?xml version="1.0" encoding="utf-8"?>
 <p:notes xmlns:a="http://schemas.openxmlformats.org/drawingml/2006/main" xmlns:r="http://schemas.openxmlformats.org/officeDocument/2006/relationships" xmlns:p="http://schemas.openxmlformats.org/presentationml/2006/main">
   <p:cSld>
     <p:spTree>
@@ -821,7 +775,7 @@
 </p:notes>
 </file>
 
-<file path=ppt/notesSlides/notesSlide13.xml><?xml version="1.0" encoding="utf-8"?>
+<file path=ppt\notesSlides\notesSlide2.xml><?xml version="1.0" encoding="utf-8"?>
 <p:notes xmlns:a="http://schemas.openxmlformats.org/drawingml/2006/main" xmlns:r="http://schemas.openxmlformats.org/officeDocument/2006/relationships" xmlns:p="http://schemas.openxmlformats.org/presentationml/2006/main">
   <p:cSld>
     <p:spTree>
@@ -890,7 +844,7 @@
           <a:p>
             <a:fld id="{F7021451-1387-4CA6-816F-3879F97B5CBC}" type="slidenum">
               <a:rPr lang="en-US"/>
-              <a:t>13</a:t>
+              <a:t>2</a:t>
             </a:fld>
             <a:endParaRPr lang="en-US"/>
           </a:p>
@@ -909,7 +863,7 @@
 </p:notes>
 </file>
 
-<file path=ppt/notesSlides/notesSlide14.xml><?xml version="1.0" encoding="utf-8"?>
+<file path=ppt\notesSlides\notesSlide3.xml><?xml version="1.0" encoding="utf-8"?>
 <p:notes xmlns:a="http://schemas.openxmlformats.org/drawingml/2006/main" xmlns:r="http://schemas.openxmlformats.org/officeDocument/2006/relationships" xmlns:p="http://schemas.openxmlformats.org/presentationml/2006/main">
   <p:cSld>
     <p:spTree>
@@ -978,7 +932,7 @@
           <a:p>
             <a:fld id="{F7021451-1387-4CA6-816F-3879F97B5CBC}" type="slidenum">
               <a:rPr lang="en-US"/>
-              <a:t>14</a:t>
+              <a:t>3</a:t>
             </a:fld>
             <a:endParaRPr lang="en-US"/>
           </a:p>
@@ -997,7 +951,7 @@
 </p:notes>
 </file>
 
-<file path=ppt/notesSlides/notesSlide2.xml><?xml version="1.0" encoding="utf-8"?>
+<file path=ppt\notesSlides\notesSlide4.xml><?xml version="1.0" encoding="utf-8"?>
 <p:notes xmlns:a="http://schemas.openxmlformats.org/drawingml/2006/main" xmlns:r="http://schemas.openxmlformats.org/officeDocument/2006/relationships" xmlns:p="http://schemas.openxmlformats.org/presentationml/2006/main">
   <p:cSld>
     <p:spTree>
@@ -1066,7 +1020,7 @@
           <a:p>
             <a:fld id="{F7021451-1387-4CA6-816F-3879F97B5CBC}" type="slidenum">
               <a:rPr lang="en-US"/>
-              <a:t>2</a:t>
+              <a:t>4</a:t>
             </a:fld>
             <a:endParaRPr lang="en-US"/>
           </a:p>
@@ -1085,7 +1039,7 @@
 </p:notes>
 </file>
 
-<file path=ppt/notesSlides/notesSlide3.xml><?xml version="1.0" encoding="utf-8"?>
+<file path=ppt\notesSlides\notesSlide5.xml><?xml version="1.0" encoding="utf-8"?>
 <p:notes xmlns:a="http://schemas.openxmlformats.org/drawingml/2006/main" xmlns:r="http://schemas.openxmlformats.org/officeDocument/2006/relationships" xmlns:p="http://schemas.openxmlformats.org/presentationml/2006/main">
   <p:cSld>
     <p:spTree>
@@ -1154,7 +1108,7 @@
           <a:p>
             <a:fld id="{F7021451-1387-4CA6-816F-3879F97B5CBC}" type="slidenum">
               <a:rPr lang="en-US"/>
-              <a:t>3</a:t>
+              <a:t>5</a:t>
             </a:fld>
             <a:endParaRPr lang="en-US"/>
           </a:p>
@@ -1173,7 +1127,7 @@
 </p:notes>
 </file>
 
-<file path=ppt/notesSlides/notesSlide4.xml><?xml version="1.0" encoding="utf-8"?>
+<file path=ppt\notesSlides\notesSlide6.xml><?xml version="1.0" encoding="utf-8"?>
 <p:notes xmlns:a="http://schemas.openxmlformats.org/drawingml/2006/main" xmlns:r="http://schemas.openxmlformats.org/officeDocument/2006/relationships" xmlns:p="http://schemas.openxmlformats.org/presentationml/2006/main">
   <p:cSld>
     <p:spTree>
@@ -1242,7 +1196,7 @@
           <a:p>
             <a:fld id="{F7021451-1387-4CA6-816F-3879F97B5CBC}" type="slidenum">
               <a:rPr lang="en-US"/>
-              <a:t>4</a:t>
+              <a:t>6</a:t>
             </a:fld>
             <a:endParaRPr lang="en-US"/>
           </a:p>
@@ -1261,7 +1215,7 @@
 </p:notes>
 </file>
 
-<file path=ppt/notesSlides/notesSlide5.xml><?xml version="1.0" encoding="utf-8"?>
+<file path=ppt\notesSlides\notesSlide7.xml><?xml version="1.0" encoding="utf-8"?>
 <p:notes xmlns:a="http://schemas.openxmlformats.org/drawingml/2006/main" xmlns:r="http://schemas.openxmlformats.org/officeDocument/2006/relationships" xmlns:p="http://schemas.openxmlformats.org/presentationml/2006/main">
   <p:cSld>
     <p:spTree>
@@ -1330,7 +1284,7 @@
           <a:p>
             <a:fld id="{F7021451-1387-4CA6-816F-3879F97B5CBC}" type="slidenum">
               <a:rPr lang="en-US"/>
-              <a:t>5</a:t>
+              <a:t>7</a:t>
             </a:fld>
             <a:endParaRPr lang="en-US"/>
           </a:p>
@@ -1349,7 +1303,7 @@
 </p:notes>
 </file>
 
-<file path=ppt/notesSlides/notesSlide6.xml><?xml version="1.0" encoding="utf-8"?>
+<file path=ppt\notesSlides\notesSlide8.xml><?xml version="1.0" encoding="utf-8"?>
 <p:notes xmlns:a="http://schemas.openxmlformats.org/drawingml/2006/main" xmlns:r="http://schemas.openxmlformats.org/officeDocument/2006/relationships" xmlns:p="http://schemas.openxmlformats.org/presentationml/2006/main">
   <p:cSld>
     <p:spTree>
@@ -1418,7 +1372,7 @@
           <a:p>
             <a:fld id="{F7021451-1387-4CA6-816F-3879F97B5CBC}" type="slidenum">
               <a:rPr lang="en-US"/>
-              <a:t>6</a:t>
+              <a:t>8</a:t>
             </a:fld>
             <a:endParaRPr lang="en-US"/>
           </a:p>
@@ -1437,7 +1391,7 @@
 </p:notes>
 </file>
 
-<file path=ppt/notesSlides/notesSlide7.xml><?xml version="1.0" encoding="utf-8"?>
+<file path=ppt\notesSlides\notesSlide9.xml><?xml version="1.0" encoding="utf-8"?>
 <p:notes xmlns:a="http://schemas.openxmlformats.org/drawingml/2006/main" xmlns:r="http://schemas.openxmlformats.org/officeDocument/2006/relationships" xmlns:p="http://schemas.openxmlformats.org/presentationml/2006/main">
   <p:cSld>
     <p:spTree>
@@ -1506,7 +1460,7 @@
           <a:p>
             <a:fld id="{F7021451-1387-4CA6-816F-3879F97B5CBC}" type="slidenum">
               <a:rPr lang="en-US"/>
-              <a:t>7</a:t>
+              <a:t>9</a:t>
             </a:fld>
             <a:endParaRPr lang="en-US"/>
           </a:p>
@@ -1525,183 +1479,130 @@
 </p:notes>
 </file>
 
-<file path=ppt/notesSlides/notesSlide8.xml><?xml version="1.0" encoding="utf-8"?>
-<p:notes xmlns:a="http://schemas.openxmlformats.org/drawingml/2006/main" xmlns:r="http://schemas.openxmlformats.org/officeDocument/2006/relationships" xmlns:p="http://schemas.openxmlformats.org/presentationml/2006/main">
-  <p:cSld>
-    <p:spTree>
-      <p:nvGrpSpPr>
-        <p:cNvPr id="1" name=""/>
-        <p:cNvGrpSpPr/>
-        <p:nvPr/>
-      </p:nvGrpSpPr>
-      <p:grpSpPr>
-        <a:xfrm>
-          <a:off x="0" y="0"/>
-          <a:ext cx="0" cy="0"/>
-          <a:chOff x="0" y="0"/>
-          <a:chExt cx="0" cy="0"/>
-        </a:xfrm>
-      </p:grpSpPr>
-      <p:sp>
-        <p:nvSpPr>
-          <p:cNvPr id="2" name="Slide Image Placeholder 1"/>
-          <p:cNvSpPr>
-            <a:spLocks noGrp="1" noRot="1" noChangeAspect="1"/>
-          </p:cNvSpPr>
-          <p:nvPr>
-            <p:ph type="sldImg"/>
-          </p:nvPr>
-        </p:nvSpPr>
-        <p:spPr/>
-      </p:sp>
-      <p:sp>
-        <p:nvSpPr>
-          <p:cNvPr id="3" name="Notes Placeholder 2"/>
-          <p:cNvSpPr>
-            <a:spLocks noGrp="1"/>
-          </p:cNvSpPr>
-          <p:nvPr>
-            <p:ph type="body" idx="1"/>
-          </p:nvPr>
-        </p:nvSpPr>
-        <p:spPr/>
-        <p:txBody>
-          <a:bodyPr/>
-          <a:lstStyle/>
-          <a:p>
-            <a:r>
-              <a:rPr lang="en-US" dirty="0"/>
-              <a:t/>
-            </a:r>
-            <a:endParaRPr lang="en-US" dirty="0"/>
-          </a:p>
-        </p:txBody>
-      </p:sp>
-      <p:sp>
-        <p:nvSpPr>
-          <p:cNvPr id="4" name="Slide Number Placeholder 3"/>
-          <p:cNvSpPr>
-            <a:spLocks noGrp="1"/>
-          </p:cNvSpPr>
-          <p:nvPr>
-            <p:ph type="sldNum" sz="quarter" idx="10"/>
-          </p:nvPr>
-        </p:nvSpPr>
-        <p:spPr/>
-        <p:txBody>
-          <a:bodyPr/>
-          <a:lstStyle/>
-          <a:p>
-            <a:fld id="{F7021451-1387-4CA6-816F-3879F97B5CBC}" type="slidenum">
-              <a:rPr lang="en-US"/>
-              <a:t>8</a:t>
-            </a:fld>
-            <a:endParaRPr lang="en-US"/>
-          </a:p>
-        </p:txBody>
-      </p:sp>
-    </p:spTree>
-    <p:extLst>
-      <p:ext uri="{BB962C8B-B14F-4D97-AF65-F5344CB8AC3E}">
-        <p14:creationId xmlns:p14="http://schemas.microsoft.com/office/powerpoint/2010/main" val="1024086991"/>
-      </p:ext>
-    </p:extLst>
-  </p:cSld>
-  <p:clrMapOvr>
-    <a:masterClrMapping/>
-  </p:clrMapOvr>
-</p:notes>
+<file path=ppt\presProps.xml><?xml version="1.0" encoding="utf-8"?>
+<p:presentationPr xmlns:a="http://schemas.openxmlformats.org/drawingml/2006/main" xmlns:r="http://schemas.openxmlformats.org/officeDocument/2006/relationships" xmlns:p="http://schemas.openxmlformats.org/presentationml/2006/main"/>
 </file>
 
-<file path=ppt/notesSlides/notesSlide9.xml><?xml version="1.0" encoding="utf-8"?>
-<p:notes xmlns:a="http://schemas.openxmlformats.org/drawingml/2006/main" xmlns:r="http://schemas.openxmlformats.org/officeDocument/2006/relationships" xmlns:p="http://schemas.openxmlformats.org/presentationml/2006/main">
-  <p:cSld>
-    <p:spTree>
-      <p:nvGrpSpPr>
-        <p:cNvPr id="1" name=""/>
-        <p:cNvGrpSpPr/>
-        <p:nvPr/>
-      </p:nvGrpSpPr>
-      <p:grpSpPr>
-        <a:xfrm>
-          <a:off x="0" y="0"/>
-          <a:ext cx="0" cy="0"/>
-          <a:chOff x="0" y="0"/>
-          <a:chExt cx="0" cy="0"/>
-        </a:xfrm>
-      </p:grpSpPr>
-      <p:sp>
-        <p:nvSpPr>
-          <p:cNvPr id="2" name="Slide Image Placeholder 1"/>
-          <p:cNvSpPr>
-            <a:spLocks noGrp="1" noRot="1" noChangeAspect="1"/>
-          </p:cNvSpPr>
-          <p:nvPr>
-            <p:ph type="sldImg"/>
-          </p:nvPr>
-        </p:nvSpPr>
-        <p:spPr/>
-      </p:sp>
-      <p:sp>
-        <p:nvSpPr>
-          <p:cNvPr id="3" name="Notes Placeholder 2"/>
-          <p:cNvSpPr>
-            <a:spLocks noGrp="1"/>
-          </p:cNvSpPr>
-          <p:nvPr>
-            <p:ph type="body" idx="1"/>
-          </p:nvPr>
-        </p:nvSpPr>
-        <p:spPr/>
-        <p:txBody>
-          <a:bodyPr/>
-          <a:lstStyle/>
-          <a:p>
-            <a:r>
-              <a:rPr lang="en-US" dirty="0"/>
-              <a:t/>
-            </a:r>
-            <a:endParaRPr lang="en-US" dirty="0"/>
-          </a:p>
-        </p:txBody>
-      </p:sp>
-      <p:sp>
-        <p:nvSpPr>
-          <p:cNvPr id="4" name="Slide Number Placeholder 3"/>
-          <p:cNvSpPr>
-            <a:spLocks noGrp="1"/>
-          </p:cNvSpPr>
-          <p:nvPr>
-            <p:ph type="sldNum" sz="quarter" idx="10"/>
-          </p:nvPr>
-        </p:nvSpPr>
-        <p:spPr/>
-        <p:txBody>
-          <a:bodyPr/>
-          <a:lstStyle/>
-          <a:p>
-            <a:fld id="{F7021451-1387-4CA6-816F-3879F97B5CBC}" type="slidenum">
-              <a:rPr lang="en-US"/>
-              <a:t>9</a:t>
-            </a:fld>
-            <a:endParaRPr lang="en-US"/>
-          </a:p>
-        </p:txBody>
-      </p:sp>
-    </p:spTree>
-    <p:extLst>
-      <p:ext uri="{BB962C8B-B14F-4D97-AF65-F5344CB8AC3E}">
-        <p14:creationId xmlns:p14="http://schemas.microsoft.com/office/powerpoint/2010/main" val="1024086991"/>
-      </p:ext>
-    </p:extLst>
-  </p:cSld>
-  <p:clrMapOvr>
-    <a:masterClrMapping/>
-  </p:clrMapOvr>
-</p:notes>
+<file path=ppt\presentation.xml><?xml version="1.0" encoding="utf-8"?>
+<p:presentation xmlns:a="http://schemas.openxmlformats.org/drawingml/2006/main" xmlns:r="http://schemas.openxmlformats.org/officeDocument/2006/relationships" xmlns:p="http://schemas.openxmlformats.org/presentationml/2006/main" saveSubsetFonts="1" autoCompressPictures="0">
+  <p:sldMasterIdLst>
+    <p:sldMasterId id="2147483648" r:id="rId1"/>
+  </p:sldMasterIdLst>
+  <p:sldIdLst>
+    <p:sldId id="256" r:id="rId2"/>
+    <p:sldId id="257" r:id="rId3"/>
+    <p:sldId id="258" r:id="rId4"/>
+    <p:sldId id="259" r:id="rId5"/>
+    <p:sldId id="260" r:id="rId6"/>
+    <p:sldId id="261" r:id="rId7"/>
+    <p:sldId id="262" r:id="rId8"/>
+    <p:sldId id="263" r:id="rId9"/>
+    <p:sldId id="264" r:id="rId10"/>
+    <p:sldId id="265" r:id="rId11"/>
+    <p:sldId id="266" r:id="rId12"/>
+    <p:sldId id="267" r:id="rId13"/>
+  </p:sldIdLst>
+  <p:notesMasterIdLst>
+    <p:notesMasterId r:id="rId16"/>
+  </p:notesMasterIdLst>
+  <p:sldSz cx="12192000" cy="6858000"/>
+  <p:notesSz cx="6858000" cy="12192000"/>
+  <p:defaultTextStyle>
+    <a:lvl1pPr marL="0" algn="l" defTabSz="914400" rtl="0" eaLnBrk="1" latinLnBrk="0" hangingPunct="1">
+      <a:defRPr sz="1800" kern="1200">
+        <a:solidFill>
+          <a:schemeClr val="tx1"/>
+        </a:solidFill>
+        <a:latin typeface="+mn-lt"/>
+        <a:ea typeface="+mn-ea"/>
+        <a:cs typeface="+mn-cs"/>
+      </a:defRPr>
+    </a:lvl1pPr>
+    <a:lvl2pPr marL="457200" algn="l" defTabSz="914400" rtl="0" eaLnBrk="1" latinLnBrk="0" hangingPunct="1">
+      <a:defRPr sz="1800" kern="1200">
+        <a:solidFill>
+          <a:schemeClr val="tx1"/>
+        </a:solidFill>
+        <a:latin typeface="+mn-lt"/>
+        <a:ea typeface="+mn-ea"/>
+        <a:cs typeface="+mn-cs"/>
+      </a:defRPr>
+    </a:lvl2pPr>
+    <a:lvl3pPr marL="914400" algn="l" defTabSz="914400" rtl="0" eaLnBrk="1" latinLnBrk="0" hangingPunct="1">
+      <a:defRPr sz="1800" kern="1200">
+        <a:solidFill>
+          <a:schemeClr val="tx1"/>
+        </a:solidFill>
+        <a:latin typeface="+mn-lt"/>
+        <a:ea typeface="+mn-ea"/>
+        <a:cs typeface="+mn-cs"/>
+      </a:defRPr>
+    </a:lvl3pPr>
+    <a:lvl4pPr marL="1371600" algn="l" defTabSz="914400" rtl="0" eaLnBrk="1" latinLnBrk="0" hangingPunct="1">
+      <a:defRPr sz="1800" kern="1200">
+        <a:solidFill>
+          <a:schemeClr val="tx1"/>
+        </a:solidFill>
+        <a:latin typeface="+mn-lt"/>
+        <a:ea typeface="+mn-ea"/>
+        <a:cs typeface="+mn-cs"/>
+      </a:defRPr>
+    </a:lvl4pPr>
+    <a:lvl5pPr marL="1828800" algn="l" defTabSz="914400" rtl="0" eaLnBrk="1" latinLnBrk="0" hangingPunct="1">
+      <a:defRPr sz="1800" kern="1200">
+        <a:solidFill>
+          <a:schemeClr val="tx1"/>
+        </a:solidFill>
+        <a:latin typeface="+mn-lt"/>
+        <a:ea typeface="+mn-ea"/>
+        <a:cs typeface="+mn-cs"/>
+      </a:defRPr>
+    </a:lvl5pPr>
+    <a:lvl6pPr marL="2286000" algn="l" defTabSz="914400" rtl="0" eaLnBrk="1" latinLnBrk="0" hangingPunct="1">
+      <a:defRPr sz="1800" kern="1200">
+        <a:solidFill>
+          <a:schemeClr val="tx1"/>
+        </a:solidFill>
+        <a:latin typeface="+mn-lt"/>
+        <a:ea typeface="+mn-ea"/>
+        <a:cs typeface="+mn-cs"/>
+      </a:defRPr>
+    </a:lvl6pPr>
+    <a:lvl7pPr marL="2743200" algn="l" defTabSz="914400" rtl="0" eaLnBrk="1" latinLnBrk="0" hangingPunct="1">
+      <a:defRPr sz="1800" kern="1200">
+        <a:solidFill>
+          <a:schemeClr val="tx1"/>
+        </a:solidFill>
+        <a:latin typeface="+mn-lt"/>
+        <a:ea typeface="+mn-ea"/>
+        <a:cs typeface="+mn-cs"/>
+      </a:defRPr>
+    </a:lvl7pPr>
+    <a:lvl8pPr marL="3200400" algn="l" defTabSz="914400" rtl="0" eaLnBrk="1" latinLnBrk="0" hangingPunct="1">
+      <a:defRPr sz="1800" kern="1200">
+        <a:solidFill>
+          <a:schemeClr val="tx1"/>
+        </a:solidFill>
+        <a:latin typeface="+mn-lt"/>
+        <a:ea typeface="+mn-ea"/>
+        <a:cs typeface="+mn-cs"/>
+      </a:defRPr>
+    </a:lvl8pPr>
+    <a:lvl9pPr marL="3657600" algn="l" defTabSz="914400" rtl="0" eaLnBrk="1" latinLnBrk="0" hangingPunct="1">
+      <a:defRPr sz="1800" kern="1200">
+        <a:solidFill>
+          <a:schemeClr val="tx1"/>
+        </a:solidFill>
+        <a:latin typeface="+mn-lt"/>
+        <a:ea typeface="+mn-ea"/>
+        <a:cs typeface="+mn-cs"/>
+      </a:defRPr>
+    </a:lvl9pPr>
+  </p:defaultTextStyle>
+</p:presentation>
 </file>
 
-<file path=ppt/slideLayouts/slideLayout1.xml><?xml version="1.0" encoding="utf-8"?>
+<file path=ppt\slideLayouts\slideLayout1.xml><?xml version="1.0" encoding="utf-8"?>
 <p:sldLayout xmlns:a="http://schemas.openxmlformats.org/drawingml/2006/main" xmlns:r="http://schemas.openxmlformats.org/officeDocument/2006/relationships" xmlns:p="http://schemas.openxmlformats.org/presentationml/2006/main" preserve="1">
   <p:cSld name="DEFAULT">
     <p:bg>
@@ -1731,7 +1632,7 @@
 </p:sldLayout>
 </file>
 
-<file path=ppt/slideMasters/slideMaster1.xml><?xml version="1.0" encoding="utf-8"?>
+<file path=ppt\slideMasters\slideMaster1.xml><?xml version="1.0" encoding="utf-8"?>
 <p:sldMaster xmlns:a="http://schemas.openxmlformats.org/drawingml/2006/main" xmlns:r="http://schemas.openxmlformats.org/officeDocument/2006/relationships" xmlns:p="http://schemas.openxmlformats.org/presentationml/2006/main">
   <p:cSld>
     <p:spTree>
@@ -2008,7 +1909,7 @@
 </p:sldMaster>
 </file>
 
-<file path=ppt/slides/slide1.xml><?xml version="1.0" encoding="utf-8"?>
+<file path=ppt\slides\slide1.xml><?xml version="1.0" encoding="utf-8"?>
 <p:sld xmlns:a="http://schemas.openxmlformats.org/drawingml/2006/main" xmlns:r="http://schemas.openxmlformats.org/officeDocument/2006/relationships" xmlns:p="http://schemas.openxmlformats.org/presentationml/2006/main">
   <p:cSld name="Slide 1">
     <p:spTree>
@@ -2424,7 +2325,7 @@
 </p:sld>
 </file>
 
-<file path=ppt/slides/slide10.xml><?xml version="1.0" encoding="utf-8"?>
+<file path=ppt\slides\slide10.xml><?xml version="1.0" encoding="utf-8"?>
 <p:sld xmlns:a="http://schemas.openxmlformats.org/drawingml/2006/main" xmlns:r="http://schemas.openxmlformats.org/officeDocument/2006/relationships" xmlns:p="http://schemas.openxmlformats.org/presentationml/2006/main">
   <p:cSld name="Slide 10">
     <p:spTree>
@@ -3001,7 +2902,7 @@
 </p:sld>
 </file>
 
-<file path=ppt/slides/slide11.xml><?xml version="1.0" encoding="utf-8"?>
+<file path=ppt\slides\slide11.xml><?xml version="1.0" encoding="utf-8"?>
 <p:sld xmlns:a="http://schemas.openxmlformats.org/drawingml/2006/main" xmlns:r="http://schemas.openxmlformats.org/officeDocument/2006/relationships" xmlns:p="http://schemas.openxmlformats.org/presentationml/2006/main">
   <p:cSld name="Slide 11">
     <p:spTree>
@@ -3892,7 +3793,7 @@
 </p:sld>
 </file>
 
-<file path=ppt/slides/slide12.xml><?xml version="1.0" encoding="utf-8"?>
+<file path=ppt\slides\slide12.xml><?xml version="1.0" encoding="utf-8"?>
 <p:sld xmlns:a="http://schemas.openxmlformats.org/drawingml/2006/main" xmlns:r="http://schemas.openxmlformats.org/officeDocument/2006/relationships" xmlns:p="http://schemas.openxmlformats.org/presentationml/2006/main">
   <p:cSld name="Slide 12">
     <p:spTree>
@@ -4691,736 +4592,7 @@
 </p:sld>
 </file>
 
-<file path=ppt/slides/slide13.xml><?xml version="1.0" encoding="utf-8"?>
-<p:sld xmlns:a="http://schemas.openxmlformats.org/drawingml/2006/main" xmlns:r="http://schemas.openxmlformats.org/officeDocument/2006/relationships" xmlns:p="http://schemas.openxmlformats.org/presentationml/2006/main">
-  <p:cSld name="Slide 13">
-    <p:spTree>
-      <p:nvGrpSpPr>
-        <p:cNvPr id="1" name=""/>
-        <p:cNvGrpSpPr/>
-        <p:nvPr/>
-      </p:nvGrpSpPr>
-      <p:grpSpPr>
-        <a:xfrm>
-          <a:off x="0" y="0"/>
-          <a:ext cx="0" cy="0"/>
-          <a:chOff x="0" y="0"/>
-          <a:chExt cx="0" cy="0"/>
-        </a:xfrm>
-      </p:grpSpPr>
-      <p:sp>
-        <p:nvSpPr>
-          <p:cNvPr id="2" name="Shape 0"/>
-          <p:cNvSpPr/>
-          <p:nvPr/>
-        </p:nvSpPr>
-        <p:spPr>
-          <a:xfrm>
-            <a:off x="0" y="0"/>
-            <a:ext cx="12188952" cy="6858000"/>
-          </a:xfrm>
-          <a:prstGeom prst="rect">
-            <a:avLst/>
-          </a:prstGeom>
-          <a:solidFill>
-            <a:srgbClr val="1A3A5C"/>
-          </a:solidFill>
-          <a:ln w="12700">
-            <a:solidFill>
-              <a:srgbClr val="1A3A5C"/>
-            </a:solidFill>
-            <a:prstDash val="solid"/>
-          </a:ln>
-        </p:spPr>
-      </p:sp>
-      <p:sp>
-        <p:nvSpPr>
-          <p:cNvPr id="3" name="Shape 1"/>
-          <p:cNvSpPr/>
-          <p:nvPr/>
-        </p:nvSpPr>
-        <p:spPr>
-          <a:xfrm>
-            <a:off x="0" y="0"/>
-            <a:ext cx="12188952" cy="1097280"/>
-          </a:xfrm>
-          <a:prstGeom prst="rect">
-            <a:avLst/>
-          </a:prstGeom>
-          <a:solidFill>
-            <a:srgbClr val="2C7BB6"/>
-          </a:solidFill>
-          <a:ln w="12700">
-            <a:solidFill>
-              <a:srgbClr val="2C7BB6"/>
-            </a:solidFill>
-            <a:prstDash val="solid"/>
-          </a:ln>
-        </p:spPr>
-      </p:sp>
-      <p:sp>
-        <p:nvSpPr>
-          <p:cNvPr id="4" name="Text 2"/>
-          <p:cNvSpPr/>
-          <p:nvPr/>
-        </p:nvSpPr>
-        <p:spPr>
-          <a:xfrm>
-            <a:off x="365760" y="137160"/>
-            <a:ext cx="11430000" cy="822960"/>
-          </a:xfrm>
-          <a:prstGeom prst="rect">
-            <a:avLst/>
-          </a:prstGeom>
-          <a:noFill/>
-          <a:ln/>
-        </p:spPr>
-        <p:txBody>
-          <a:bodyPr wrap="square" rtlCol="0" anchor="ctr"/>
-          <a:lstStyle/>
-          <a:p>
-            <a:pPr algn="l" indent="0" marL="0">
-              <a:buNone/>
-            </a:pPr>
-            <a:r>
-              <a:rPr lang="en-US" sz="3000" b="1" dirty="0">
-                <a:solidFill>
-                  <a:srgbClr val="FFFFFF"/>
-                </a:solidFill>
-              </a:rPr>
-              <a:t>Demonstração ao Vivo 🚀</a:t>
-            </a:r>
-            <a:endParaRPr lang="en-US" sz="3000" dirty="0"/>
-          </a:p>
-        </p:txBody>
-      </p:sp>
-      <p:sp>
-        <p:nvSpPr>
-          <p:cNvPr id="5" name="Text 3"/>
-          <p:cNvSpPr/>
-          <p:nvPr/>
-        </p:nvSpPr>
-        <p:spPr>
-          <a:xfrm>
-            <a:off x="365760" y="1280160"/>
-            <a:ext cx="11430000" cy="457200"/>
-          </a:xfrm>
-          <a:prstGeom prst="rect">
-            <a:avLst/>
-          </a:prstGeom>
-          <a:noFill/>
-          <a:ln/>
-        </p:spPr>
-        <p:txBody>
-          <a:bodyPr wrap="square" rtlCol="0" anchor="t"/>
-          <a:lstStyle/>
-          <a:p>
-            <a:pPr algn="l" indent="0" marL="0">
-              <a:buNone/>
-            </a:pPr>
-            <a:r>
-              <a:rPr lang="en-US" sz="1800" dirty="0">
-                <a:solidFill>
-                  <a:srgbClr val="ABD9E9"/>
-                </a:solidFill>
-              </a:rPr>
-              <a:t>Execute no terminal:</a:t>
-            </a:r>
-            <a:endParaRPr lang="en-US" sz="1800" dirty="0"/>
-          </a:p>
-        </p:txBody>
-      </p:sp>
-      <p:sp>
-        <p:nvSpPr>
-          <p:cNvPr id="6" name="Shape 4"/>
-          <p:cNvSpPr/>
-          <p:nvPr/>
-        </p:nvSpPr>
-        <p:spPr>
-          <a:xfrm>
-            <a:off x="365760" y="1828800"/>
-            <a:ext cx="11430000" cy="1005840"/>
-          </a:xfrm>
-          <a:prstGeom prst="rect">
-            <a:avLst/>
-          </a:prstGeom>
-          <a:solidFill>
-            <a:srgbClr val="0D1117"/>
-          </a:solidFill>
-          <a:ln w="12700">
-            <a:solidFill>
-              <a:srgbClr val="0D1117"/>
-            </a:solidFill>
-            <a:prstDash val="solid"/>
-          </a:ln>
-        </p:spPr>
-      </p:sp>
-      <p:sp>
-        <p:nvSpPr>
-          <p:cNvPr id="7" name="Text 5"/>
-          <p:cNvSpPr/>
-          <p:nvPr/>
-        </p:nvSpPr>
-        <p:spPr>
-          <a:xfrm>
-            <a:off x="685800" y="1901952"/>
-            <a:ext cx="10972800" cy="868680"/>
-          </a:xfrm>
-          <a:prstGeom prst="rect">
-            <a:avLst/>
-          </a:prstGeom>
-          <a:noFill/>
-          <a:ln/>
-        </p:spPr>
-        <p:txBody>
-          <a:bodyPr wrap="square" rtlCol="0" anchor="t"/>
-          <a:lstStyle/>
-          <a:p>
-            <a:pPr algn="l" indent="0" marL="0">
-              <a:buNone/>
-            </a:pPr>
-            <a:r>
-              <a:rPr lang="en-US" sz="2400" b="1" dirty="0">
-                <a:solidFill>
-                  <a:srgbClr val="58A6FF"/>
-                </a:solidFill>
-              </a:rPr>
-              <a:t>python -X utf8 main.py</a:t>
-            </a:r>
-            <a:endParaRPr lang="en-US" sz="2400" dirty="0"/>
-          </a:p>
-        </p:txBody>
-      </p:sp>
-      <p:sp>
-        <p:nvSpPr>
-          <p:cNvPr id="8" name="Text 6"/>
-          <p:cNvSpPr/>
-          <p:nvPr/>
-        </p:nvSpPr>
-        <p:spPr>
-          <a:xfrm>
-            <a:off x="365760" y="3063240"/>
-            <a:ext cx="11430000" cy="457200"/>
-          </a:xfrm>
-          <a:prstGeom prst="rect">
-            <a:avLst/>
-          </a:prstGeom>
-          <a:noFill/>
-          <a:ln/>
-        </p:spPr>
-        <p:txBody>
-          <a:bodyPr wrap="square" rtlCol="0" anchor="t"/>
-          <a:lstStyle/>
-          <a:p>
-            <a:pPr algn="l" indent="0" marL="0">
-              <a:buNone/>
-            </a:pPr>
-            <a:r>
-              <a:rPr lang="en-US" sz="1800" dirty="0">
-                <a:solidFill>
-                  <a:srgbClr val="ABD9E9"/>
-                </a:solidFill>
-              </a:rPr>
-              <a:t>O que você vai ver:</a:t>
-            </a:r>
-            <a:endParaRPr lang="en-US" sz="1800" dirty="0"/>
-          </a:p>
-        </p:txBody>
-      </p:sp>
-      <p:sp>
-        <p:nvSpPr>
-          <p:cNvPr id="9" name="Text 7"/>
-          <p:cNvSpPr/>
-          <p:nvPr/>
-        </p:nvSpPr>
-        <p:spPr>
-          <a:xfrm>
-            <a:off x="457200" y="3611880"/>
-            <a:ext cx="11247120" cy="502920"/>
-          </a:xfrm>
-          <a:prstGeom prst="rect">
-            <a:avLst/>
-          </a:prstGeom>
-          <a:noFill/>
-          <a:ln/>
-        </p:spPr>
-        <p:txBody>
-          <a:bodyPr wrap="square" rtlCol="0" anchor="t"/>
-          <a:lstStyle/>
-          <a:p>
-            <a:pPr algn="l" indent="0" marL="0">
-              <a:buNone/>
-            </a:pPr>
-            <a:r>
-              <a:rPr lang="en-US" sz="1500" dirty="0">
-                <a:solidFill>
-                  <a:srgbClr val="FFFFFF"/>
-                </a:solidFill>
-              </a:rPr>
-              <a:t>✓  94.562 pedidos carregados do dataset Olist</a:t>
-            </a:r>
-            <a:endParaRPr lang="en-US" sz="1500" dirty="0"/>
-          </a:p>
-        </p:txBody>
-      </p:sp>
-      <p:sp>
-        <p:nvSpPr>
-          <p:cNvPr id="10" name="Text 8"/>
-          <p:cNvSpPr/>
-          <p:nvPr/>
-        </p:nvSpPr>
-        <p:spPr>
-          <a:xfrm>
-            <a:off x="457200" y="4142232"/>
-            <a:ext cx="11247120" cy="502920"/>
-          </a:xfrm>
-          <a:prstGeom prst="rect">
-            <a:avLst/>
-          </a:prstGeom>
-          <a:noFill/>
-          <a:ln/>
-        </p:spPr>
-        <p:txBody>
-          <a:bodyPr wrap="square" rtlCol="0" anchor="t"/>
-          <a:lstStyle/>
-          <a:p>
-            <a:pPr algn="l" indent="0" marL="0">
-              <a:buNone/>
-            </a:pPr>
-            <a:r>
-              <a:rPr lang="en-US" sz="1500" dirty="0">
-                <a:solidFill>
-                  <a:srgbClr val="FFFFFF"/>
-                </a:solidFill>
-              </a:rPr>
-              <a:t>✓  3 modelos treinados automaticamente</a:t>
-            </a:r>
-            <a:endParaRPr lang="en-US" sz="1500" dirty="0"/>
-          </a:p>
-        </p:txBody>
-      </p:sp>
-      <p:sp>
-        <p:nvSpPr>
-          <p:cNvPr id="11" name="Text 9"/>
-          <p:cNvSpPr/>
-          <p:nvPr/>
-        </p:nvSpPr>
-        <p:spPr>
-          <a:xfrm>
-            <a:off x="457200" y="4672584"/>
-            <a:ext cx="11247120" cy="502920"/>
-          </a:xfrm>
-          <a:prstGeom prst="rect">
-            <a:avLst/>
-          </a:prstGeom>
-          <a:noFill/>
-          <a:ln/>
-        </p:spPr>
-        <p:txBody>
-          <a:bodyPr wrap="square" rtlCol="0" anchor="t"/>
-          <a:lstStyle/>
-          <a:p>
-            <a:pPr algn="l" indent="0" marL="0">
-              <a:buNone/>
-            </a:pPr>
-            <a:r>
-              <a:rPr lang="en-US" sz="1500" dirty="0">
-                <a:solidFill>
-                  <a:srgbClr val="FFFFFF"/>
-                </a:solidFill>
-              </a:rPr>
-              <a:t>✓  Tabela de comparação de resultados</a:t>
-            </a:r>
-            <a:endParaRPr lang="en-US" sz="1500" dirty="0"/>
-          </a:p>
-        </p:txBody>
-      </p:sp>
-      <p:sp>
-        <p:nvSpPr>
-          <p:cNvPr id="12" name="Text 10"/>
-          <p:cNvSpPr/>
-          <p:nvPr/>
-        </p:nvSpPr>
-        <p:spPr>
-          <a:xfrm>
-            <a:off x="457200" y="5202936"/>
-            <a:ext cx="11247120" cy="502920"/>
-          </a:xfrm>
-          <a:prstGeom prst="rect">
-            <a:avLst/>
-          </a:prstGeom>
-          <a:noFill/>
-          <a:ln/>
-        </p:spPr>
-        <p:txBody>
-          <a:bodyPr wrap="square" rtlCol="0" anchor="t"/>
-          <a:lstStyle/>
-          <a:p>
-            <a:pPr algn="l" indent="0" marL="0">
-              <a:buNone/>
-            </a:pPr>
-            <a:r>
-              <a:rPr lang="en-US" sz="1500" dirty="0">
-                <a:solidFill>
-                  <a:srgbClr val="FFFFFF"/>
-                </a:solidFill>
-              </a:rPr>
-              <a:t>✓  4 gráficos salvos em images/</a:t>
-            </a:r>
-            <a:endParaRPr lang="en-US" sz="1500" dirty="0"/>
-          </a:p>
-        </p:txBody>
-      </p:sp>
-      <p:sp>
-        <p:nvSpPr>
-          <p:cNvPr id="13" name="Text 11"/>
-          <p:cNvSpPr/>
-          <p:nvPr/>
-        </p:nvSpPr>
-        <p:spPr>
-          <a:xfrm>
-            <a:off x="457200" y="5733288"/>
-            <a:ext cx="11247120" cy="502920"/>
-          </a:xfrm>
-          <a:prstGeom prst="rect">
-            <a:avLst/>
-          </a:prstGeom>
-          <a:noFill/>
-          <a:ln/>
-        </p:spPr>
-        <p:txBody>
-          <a:bodyPr wrap="square" rtlCol="0" anchor="t"/>
-          <a:lstStyle/>
-          <a:p>
-            <a:pPr algn="l" indent="0" marL="0">
-              <a:buNone/>
-            </a:pPr>
-            <a:r>
-              <a:rPr lang="en-US" sz="1500" dirty="0">
-                <a:solidFill>
-                  <a:srgbClr val="FFFFFF"/>
-                </a:solidFill>
-              </a:rPr>
-              <a:t>✓  Melhor modelo salvo em models/</a:t>
-            </a:r>
-            <a:endParaRPr lang="en-US" sz="1500" dirty="0"/>
-          </a:p>
-        </p:txBody>
-      </p:sp>
-    </p:spTree>
-  </p:cSld>
-  <p:clrMapOvr>
-    <a:masterClrMapping/>
-  </p:clrMapOvr>
-</p:sld>
-</file>
-
-<file path=ppt/slides/slide14.xml><?xml version="1.0" encoding="utf-8"?>
-<p:sld xmlns:a="http://schemas.openxmlformats.org/drawingml/2006/main" xmlns:r="http://schemas.openxmlformats.org/officeDocument/2006/relationships" xmlns:p="http://schemas.openxmlformats.org/presentationml/2006/main">
-  <p:cSld name="Slide 14">
-    <p:spTree>
-      <p:nvGrpSpPr>
-        <p:cNvPr id="1" name=""/>
-        <p:cNvGrpSpPr/>
-        <p:nvPr/>
-      </p:nvGrpSpPr>
-      <p:grpSpPr>
-        <a:xfrm>
-          <a:off x="0" y="0"/>
-          <a:ext cx="0" cy="0"/>
-          <a:chOff x="0" y="0"/>
-          <a:chExt cx="0" cy="0"/>
-        </a:xfrm>
-      </p:grpSpPr>
-      <p:sp>
-        <p:nvSpPr>
-          <p:cNvPr id="2" name="Shape 0"/>
-          <p:cNvSpPr/>
-          <p:nvPr/>
-        </p:nvSpPr>
-        <p:spPr>
-          <a:xfrm>
-            <a:off x="0" y="0"/>
-            <a:ext cx="12188952" cy="6858000"/>
-          </a:xfrm>
-          <a:prstGeom prst="rect">
-            <a:avLst/>
-          </a:prstGeom>
-          <a:solidFill>
-            <a:srgbClr val="1A3A5C"/>
-          </a:solidFill>
-          <a:ln w="12700">
-            <a:solidFill>
-              <a:srgbClr val="1A3A5C"/>
-            </a:solidFill>
-            <a:prstDash val="solid"/>
-          </a:ln>
-        </p:spPr>
-      </p:sp>
-      <p:sp>
-        <p:nvSpPr>
-          <p:cNvPr id="3" name="Shape 1"/>
-          <p:cNvSpPr/>
-          <p:nvPr/>
-        </p:nvSpPr>
-        <p:spPr>
-          <a:xfrm>
-            <a:off x="0" y="0"/>
-            <a:ext cx="12188952" cy="73152"/>
-          </a:xfrm>
-          <a:prstGeom prst="rect">
-            <a:avLst/>
-          </a:prstGeom>
-          <a:solidFill>
-            <a:srgbClr val="2C7BB6"/>
-          </a:solidFill>
-          <a:ln w="12700">
-            <a:solidFill>
-              <a:srgbClr val="2C7BB6"/>
-            </a:solidFill>
-            <a:prstDash val="solid"/>
-          </a:ln>
-        </p:spPr>
-      </p:sp>
-      <p:sp>
-        <p:nvSpPr>
-          <p:cNvPr id="4" name="Shape 2"/>
-          <p:cNvSpPr/>
-          <p:nvPr/>
-        </p:nvSpPr>
-        <p:spPr>
-          <a:xfrm>
-            <a:off x="0" y="6784848"/>
-            <a:ext cx="12188952" cy="73152"/>
-          </a:xfrm>
-          <a:prstGeom prst="rect">
-            <a:avLst/>
-          </a:prstGeom>
-          <a:solidFill>
-            <a:srgbClr val="2C7BB6"/>
-          </a:solidFill>
-          <a:ln w="12700">
-            <a:solidFill>
-              <a:srgbClr val="2C7BB6"/>
-            </a:solidFill>
-            <a:prstDash val="solid"/>
-          </a:ln>
-        </p:spPr>
-      </p:sp>
-      <p:sp>
-        <p:nvSpPr>
-          <p:cNvPr id="5" name="Text 3"/>
-          <p:cNvSpPr/>
-          <p:nvPr/>
-        </p:nvSpPr>
-        <p:spPr>
-          <a:xfrm>
-            <a:off x="365760" y="914400"/>
-            <a:ext cx="11457432" cy="1097280"/>
-          </a:xfrm>
-          <a:prstGeom prst="rect">
-            <a:avLst/>
-          </a:prstGeom>
-          <a:noFill/>
-          <a:ln/>
-        </p:spPr>
-        <p:txBody>
-          <a:bodyPr wrap="square" rtlCol="0" anchor="t"/>
-          <a:lstStyle/>
-          <a:p>
-            <a:pPr algn="ctr" indent="0" marL="0">
-              <a:buNone/>
-            </a:pPr>
-            <a:r>
-              <a:rPr lang="en-US" sz="5200" dirty="0">
-                <a:solidFill>
-                  <a:srgbClr val="2C3E50"/>
-                </a:solidFill>
-              </a:rPr>
-              <a:t>🙏</a:t>
-            </a:r>
-            <a:endParaRPr lang="en-US" sz="5200" dirty="0"/>
-          </a:p>
-        </p:txBody>
-      </p:sp>
-      <p:sp>
-        <p:nvSpPr>
-          <p:cNvPr id="6" name="Text 4"/>
-          <p:cNvSpPr/>
-          <p:nvPr/>
-        </p:nvSpPr>
-        <p:spPr>
-          <a:xfrm>
-            <a:off x="0" y="2011680"/>
-            <a:ext cx="12188952" cy="914400"/>
-          </a:xfrm>
-          <a:prstGeom prst="rect">
-            <a:avLst/>
-          </a:prstGeom>
-          <a:noFill/>
-          <a:ln/>
-        </p:spPr>
-        <p:txBody>
-          <a:bodyPr wrap="square" rtlCol="0" anchor="t"/>
-          <a:lstStyle/>
-          <a:p>
-            <a:pPr algn="ctr" indent="0" marL="0">
-              <a:buNone/>
-            </a:pPr>
-            <a:r>
-              <a:rPr lang="en-US" sz="5200" b="1" dirty="0">
-                <a:solidFill>
-                  <a:srgbClr val="FFFFFF"/>
-                </a:solidFill>
-              </a:rPr>
-              <a:t>Obrigado!</a:t>
-            </a:r>
-            <a:endParaRPr lang="en-US" sz="5200" dirty="0"/>
-          </a:p>
-        </p:txBody>
-      </p:sp>
-      <p:sp>
-        <p:nvSpPr>
-          <p:cNvPr id="7" name="Text 5"/>
-          <p:cNvSpPr/>
-          <p:nvPr/>
-        </p:nvSpPr>
-        <p:spPr>
-          <a:xfrm>
-            <a:off x="0" y="2926080"/>
-            <a:ext cx="12188952" cy="640080"/>
-          </a:xfrm>
-          <a:prstGeom prst="rect">
-            <a:avLst/>
-          </a:prstGeom>
-          <a:noFill/>
-          <a:ln/>
-        </p:spPr>
-        <p:txBody>
-          <a:bodyPr wrap="square" rtlCol="0" anchor="t"/>
-          <a:lstStyle/>
-          <a:p>
-            <a:pPr algn="ctr" indent="0" marL="0">
-              <a:buNone/>
-            </a:pPr>
-            <a:r>
-              <a:rPr lang="en-US" sz="2600" dirty="0">
-                <a:solidFill>
-                  <a:srgbClr val="ABD9E9"/>
-                </a:solidFill>
-              </a:rPr>
-              <a:t>Dúvidas?</a:t>
-            </a:r>
-            <a:endParaRPr lang="en-US" sz="2600" dirty="0"/>
-          </a:p>
-        </p:txBody>
-      </p:sp>
-      <p:sp>
-        <p:nvSpPr>
-          <p:cNvPr id="8" name="Shape 6"/>
-          <p:cNvSpPr/>
-          <p:nvPr/>
-        </p:nvSpPr>
-        <p:spPr>
-          <a:xfrm>
-            <a:off x="1371600" y="3840480"/>
-            <a:ext cx="9418320" cy="1645920"/>
-          </a:xfrm>
-          <a:prstGeom prst="rect">
-            <a:avLst/>
-          </a:prstGeom>
-          <a:solidFill>
-            <a:srgbClr val="2C7BB6"/>
-          </a:solidFill>
-          <a:ln w="12700">
-            <a:solidFill>
-              <a:srgbClr val="2C7BB6"/>
-            </a:solidFill>
-            <a:prstDash val="solid"/>
-          </a:ln>
-        </p:spPr>
-      </p:sp>
-      <p:sp>
-        <p:nvSpPr>
-          <p:cNvPr id="9" name="Text 7"/>
-          <p:cNvSpPr/>
-          <p:nvPr/>
-        </p:nvSpPr>
-        <p:spPr>
-          <a:xfrm>
-            <a:off x="1371600" y="4160520"/>
-            <a:ext cx="9418320" cy="822960"/>
-          </a:xfrm>
-          <a:prstGeom prst="rect">
-            <a:avLst/>
-          </a:prstGeom>
-          <a:noFill/>
-          <a:ln/>
-        </p:spPr>
-        <p:txBody>
-          <a:bodyPr wrap="square" rtlCol="0" anchor="t"/>
-          <a:lstStyle/>
-          <a:p>
-            <a:pPr algn="ctr" indent="0" marL="0">
-              <a:buNone/>
-            </a:pPr>
-            <a:r>
-              <a:rPr lang="en-US" sz="1500" b="1" dirty="0">
-                <a:solidFill>
-                  <a:srgbClr val="FFFFFF"/>
-                </a:solidFill>
-              </a:rPr>
-              <a:t>94.562 pedidos  ·  3 algoritmos  ·  R² = 1,0000  ·  Erro médio: R$ 0,78</a:t>
-            </a:r>
-            <a:endParaRPr lang="en-US" sz="1500" dirty="0"/>
-          </a:p>
-        </p:txBody>
-      </p:sp>
-      <p:sp>
-        <p:nvSpPr>
-          <p:cNvPr id="10" name="Text 8"/>
-          <p:cNvSpPr/>
-          <p:nvPr/>
-        </p:nvSpPr>
-        <p:spPr>
-          <a:xfrm>
-            <a:off x="0" y="6035040"/>
-            <a:ext cx="12188952" cy="457200"/>
-          </a:xfrm>
-          <a:prstGeom prst="rect">
-            <a:avLst/>
-          </a:prstGeom>
-          <a:noFill/>
-          <a:ln/>
-        </p:spPr>
-        <p:txBody>
-          <a:bodyPr wrap="square" rtlCol="0" anchor="t"/>
-          <a:lstStyle/>
-          <a:p>
-            <a:pPr algn="ctr" indent="0" marL="0">
-              <a:buNone/>
-            </a:pPr>
-            <a:r>
-              <a:rPr lang="en-US" sz="1400" dirty="0">
-                <a:solidFill>
-                  <a:srgbClr val="7F8C8D"/>
-                </a:solidFill>
-              </a:rPr>
-              <a:t>github.com/gustavofelipeelsner/ecommerce</a:t>
-            </a:r>
-            <a:endParaRPr lang="en-US" sz="1400" dirty="0"/>
-          </a:p>
-        </p:txBody>
-      </p:sp>
-    </p:spTree>
-  </p:cSld>
-  <p:clrMapOvr>
-    <a:masterClrMapping/>
-  </p:clrMapOvr>
-</p:sld>
-</file>
-
-<file path=ppt/slides/slide2.xml><?xml version="1.0" encoding="utf-8"?>
+<file path=ppt\slides\slide2.xml><?xml version="1.0" encoding="utf-8"?>
 <p:sld xmlns:a="http://schemas.openxmlformats.org/drawingml/2006/main" xmlns:r="http://schemas.openxmlformats.org/officeDocument/2006/relationships" xmlns:p="http://schemas.openxmlformats.org/presentationml/2006/main">
   <p:cSld name="Slide 2">
     <p:spTree>
@@ -6108,7 +5280,7 @@
 </p:sld>
 </file>
 
-<file path=ppt/slides/slide3.xml><?xml version="1.0" encoding="utf-8"?>
+<file path=ppt\slides\slide3.xml><?xml version="1.0" encoding="utf-8"?>
 <p:sld xmlns:a="http://schemas.openxmlformats.org/drawingml/2006/main" xmlns:r="http://schemas.openxmlformats.org/officeDocument/2006/relationships" xmlns:p="http://schemas.openxmlformats.org/presentationml/2006/main">
   <p:cSld name="Slide 3">
     <p:spTree>
@@ -7365,7 +6537,7 @@
 </p:sld>
 </file>
 
-<file path=ppt/slides/slide4.xml><?xml version="1.0" encoding="utf-8"?>
+<file path=ppt\slides\slide4.xml><?xml version="1.0" encoding="utf-8"?>
 <p:sld xmlns:a="http://schemas.openxmlformats.org/drawingml/2006/main" xmlns:r="http://schemas.openxmlformats.org/officeDocument/2006/relationships" xmlns:p="http://schemas.openxmlformats.org/presentationml/2006/main">
   <p:cSld name="Slide 4">
     <p:spTree>
@@ -8516,7 +7688,7 @@
 </p:sld>
 </file>
 
-<file path=ppt/slides/slide5.xml><?xml version="1.0" encoding="utf-8"?>
+<file path=ppt\slides\slide5.xml><?xml version="1.0" encoding="utf-8"?>
 <p:sld xmlns:a="http://schemas.openxmlformats.org/drawingml/2006/main" xmlns:r="http://schemas.openxmlformats.org/officeDocument/2006/relationships" xmlns:p="http://schemas.openxmlformats.org/presentationml/2006/main">
   <p:cSld name="Slide 5">
     <p:spTree>
@@ -9018,7 +8190,7 @@
 </p:sld>
 </file>
 
-<file path=ppt/slides/slide6.xml><?xml version="1.0" encoding="utf-8"?>
+<file path=ppt\slides\slide6.xml><?xml version="1.0" encoding="utf-8"?>
 <p:sld xmlns:a="http://schemas.openxmlformats.org/drawingml/2006/main" xmlns:r="http://schemas.openxmlformats.org/officeDocument/2006/relationships" xmlns:p="http://schemas.openxmlformats.org/presentationml/2006/main">
   <p:cSld name="Slide 6">
     <p:spTree>
@@ -9606,7 +8778,7 @@
 </p:sld>
 </file>
 
-<file path=ppt/slides/slide7.xml><?xml version="1.0" encoding="utf-8"?>
+<file path=ppt\slides\slide7.xml><?xml version="1.0" encoding="utf-8"?>
 <p:sld xmlns:a="http://schemas.openxmlformats.org/drawingml/2006/main" xmlns:r="http://schemas.openxmlformats.org/officeDocument/2006/relationships" xmlns:p="http://schemas.openxmlformats.org/presentationml/2006/main">
   <p:cSld name="Slide 7">
     <p:spTree>
@@ -10208,7 +9380,7 @@
 </p:sld>
 </file>
 
-<file path=ppt/slides/slide8.xml><?xml version="1.0" encoding="utf-8"?>
+<file path=ppt\slides\slide8.xml><?xml version="1.0" encoding="utf-8"?>
 <p:sld xmlns:a="http://schemas.openxmlformats.org/drawingml/2006/main" xmlns:r="http://schemas.openxmlformats.org/officeDocument/2006/relationships" xmlns:p="http://schemas.openxmlformats.org/presentationml/2006/main">
   <p:cSld name="Slide 8">
     <p:spTree>
@@ -10810,7 +9982,7 @@
 </p:sld>
 </file>
 
-<file path=ppt/slides/slide9.xml><?xml version="1.0" encoding="utf-8"?>
+<file path=ppt\slides\slide9.xml><?xml version="1.0" encoding="utf-8"?>
 <p:sld xmlns:a="http://schemas.openxmlformats.org/drawingml/2006/main" xmlns:r="http://schemas.openxmlformats.org/officeDocument/2006/relationships" xmlns:p="http://schemas.openxmlformats.org/presentationml/2006/main">
   <p:cSld name="Slide 9">
     <p:spTree>
@@ -11680,7 +10852,11 @@
 </p:sld>
 </file>
 
-<file path=ppt/theme/theme1.xml><?xml version="1.0" encoding="utf-8"?>
+<file path=ppt\tableStyles.xml><?xml version="1.0" encoding="utf-8"?>
+<a:tblStyleLst xmlns:a="http://schemas.openxmlformats.org/drawingml/2006/main" def="{5C22544A-7EE6-4342-B048-85BDC9FD1C3A}"/>
+</file>
+
+<file path=ppt\theme\theme1.xml><?xml version="1.0" encoding="utf-8"?>
 <a:theme xmlns:a="http://schemas.openxmlformats.org/drawingml/2006/main" name="Office Theme">
   <a:themeElements>
     <a:clrScheme name="Office">
@@ -11973,4 +11149,35 @@
     </a:ext>
   </a:extLst>
 </a:theme>
+</file>
+
+<file path=ppt\viewProps.xml><?xml version="1.0" encoding="utf-8"?>
+<p:viewPr xmlns:a="http://schemas.openxmlformats.org/drawingml/2006/main" xmlns:r="http://schemas.openxmlformats.org/officeDocument/2006/relationships" xmlns:p="http://schemas.openxmlformats.org/presentationml/2006/main">
+  <p:normalViewPr horzBarState="maximized">
+    <p:restoredLeft sz="15611"/>
+    <p:restoredTop sz="94610"/>
+  </p:normalViewPr>
+  <p:slideViewPr>
+    <p:cSldViewPr snapToGrid="0" snapToObjects="1">
+      <p:cViewPr varScale="1">
+        <p:scale>
+          <a:sx n="136" d="100"/>
+          <a:sy n="136" d="100"/>
+        </p:scale>
+        <p:origin x="216" y="312"/>
+      </p:cViewPr>
+      <p:guideLst/>
+    </p:cSldViewPr>
+  </p:slideViewPr>
+  <p:notesTextViewPr>
+    <p:cViewPr>
+      <p:scale>
+        <a:sx n="1" d="1"/>
+        <a:sy n="1" d="1"/>
+      </p:scale>
+      <p:origin x="0" y="0"/>
+    </p:cViewPr>
+  </p:notesTextViewPr>
+  <p:gridSpacing cx="76200" cy="76200"/>
+</p:viewPr>
 </file>
</xml_diff>